<commit_message>
Correct canonical Ecosystem Positioning presentation routing
</commit_message>
<xml_diff>
--- a/presentations/ecosystem-positioning/Ecosystem_Positioning_Canonical.pptx
+++ b/presentations/ecosystem-positioning/Ecosystem_Positioning_Canonical.pptx
@@ -3369,7 +3369,7 @@
 </file>
 
 <file path=ppt/slides/slide10.xml><?xml version="1.0" encoding="utf-8"?>
-<p:sld xmlns:a="http://schemas.openxmlformats.org/drawingml/2006/main" xmlns:r="http://schemas.openxmlformats.org/officeDocument/2006/relationships" xmlns:p="http://schemas.openxmlformats.org/presentationml/2006/main">
+<p:sld xmlns:a="http://schemas.openxmlformats.org/drawingml/2006/main" xmlns:ns2="http://schemas.microsoft.com/office/drawing/2014/main" xmlns:ns4="http://schemas.microsoft.com/office/powerpoint/2010/main" xmlns:p="http://schemas.openxmlformats.org/presentationml/2006/main" xmlns:r="http://schemas.openxmlformats.org/officeDocument/2006/relationships">
   <p:cSld>
     <p:spTree>
       <p:nvGrpSpPr>
@@ -3390,7 +3390,7 @@
           <p:cNvPr id="2" name="TextBox 1">
             <a:extLst>
               <a:ext uri="{FF2B5EF4-FFF2-40B4-BE49-F238E27FC236}">
-                <a16:creationId xmlns:a16="http://schemas.microsoft.com/office/drawing/2014/main" id="{DC7B49D2-A900-4CD5-88BB-A23F38A48EF3}"/>
+                <ns2:creationId id="{DC7B49D2-A900-4CD5-88BB-A23F38A48EF3}"/>
               </a:ext>
             </a:extLst>
           </p:cNvPr>
@@ -3440,7 +3440,7 @@
           <p:cNvPr id="3" name="Rectangle 2">
             <a:extLst>
               <a:ext uri="{FF2B5EF4-FFF2-40B4-BE49-F238E27FC236}">
-                <a16:creationId xmlns:a16="http://schemas.microsoft.com/office/drawing/2014/main" id="{1FED8D69-4758-4579-A6CD-B39481A7F0AD}"/>
+                <ns2:creationId id="{1FED8D69-4758-4579-A6CD-B39481A7F0AD}"/>
               </a:ext>
             </a:extLst>
           </p:cNvPr>
@@ -3494,7 +3494,7 @@
           <p:cNvPr id="4" name="TextBox 3">
             <a:extLst>
               <a:ext uri="{FF2B5EF4-FFF2-40B4-BE49-F238E27FC236}">
-                <a16:creationId xmlns:a16="http://schemas.microsoft.com/office/drawing/2014/main" id="{B105BF4F-06A7-416F-9D9A-D4F6803B29A7}"/>
+                <ns2:creationId id="{B105BF4F-06A7-416F-9D9A-D4F6803B29A7}"/>
               </a:ext>
             </a:extLst>
           </p:cNvPr>
@@ -3544,7 +3544,7 @@
           <p:cNvPr id="5" name="Rectangle 4">
             <a:extLst>
               <a:ext uri="{FF2B5EF4-FFF2-40B4-BE49-F238E27FC236}">
-                <a16:creationId xmlns:a16="http://schemas.microsoft.com/office/drawing/2014/main" id="{FF84DEB9-98D0-4601-AEC8-B3D51FF7E084}"/>
+                <ns2:creationId id="{FF84DEB9-98D0-4601-AEC8-B3D51FF7E084}"/>
               </a:ext>
             </a:extLst>
           </p:cNvPr>
@@ -3598,7 +3598,7 @@
           <p:cNvPr id="6" name="TextBox 5">
             <a:extLst>
               <a:ext uri="{FF2B5EF4-FFF2-40B4-BE49-F238E27FC236}">
-                <a16:creationId xmlns:a16="http://schemas.microsoft.com/office/drawing/2014/main" id="{D028E49D-0AB2-426A-B39B-0FA221F9000C}"/>
+                <ns2:creationId id="{D028E49D-0AB2-426A-B39B-0FA221F9000C}"/>
               </a:ext>
             </a:extLst>
           </p:cNvPr>
@@ -3648,7 +3648,7 @@
           <p:cNvPr id="7" name="TextBox 6">
             <a:extLst>
               <a:ext uri="{FF2B5EF4-FFF2-40B4-BE49-F238E27FC236}">
-                <a16:creationId xmlns:a16="http://schemas.microsoft.com/office/drawing/2014/main" id="{CE09CB74-AA60-470C-B8EB-6FC7C385A25E}"/>
+                <ns2:creationId id="{CE09CB74-AA60-470C-B8EB-6FC7C385A25E}"/>
               </a:ext>
             </a:extLst>
           </p:cNvPr>
@@ -3698,7 +3698,7 @@
           <p:cNvPr id="8" name="TextBox 7">
             <a:extLst>
               <a:ext uri="{FF2B5EF4-FFF2-40B4-BE49-F238E27FC236}">
-                <a16:creationId xmlns:a16="http://schemas.microsoft.com/office/drawing/2014/main" id="{9709FC97-FC2D-4E96-B25A-54DCA3B6BC2B}"/>
+                <ns2:creationId id="{9709FC97-FC2D-4E96-B25A-54DCA3B6BC2B}"/>
               </a:ext>
             </a:extLst>
           </p:cNvPr>
@@ -3748,7 +3748,7 @@
           <p:cNvPr id="9" name="TextBox 8">
             <a:extLst>
               <a:ext uri="{FF2B5EF4-FFF2-40B4-BE49-F238E27FC236}">
-                <a16:creationId xmlns:a16="http://schemas.microsoft.com/office/drawing/2014/main" id="{E45187D6-D5CB-4179-B777-1EF47166DD00}"/>
+                <ns2:creationId id="{E45187D6-D5CB-4179-B777-1EF47166DD00}"/>
               </a:ext>
             </a:extLst>
           </p:cNvPr>
@@ -3825,7 +3825,7 @@
           <p:cNvPr id="10" name="TextBox 9">
             <a:extLst>
               <a:ext uri="{FF2B5EF4-FFF2-40B4-BE49-F238E27FC236}">
-                <a16:creationId xmlns:a16="http://schemas.microsoft.com/office/drawing/2014/main" id="{F363CDB4-E6DD-4E95-91B4-90BDE4A8D981}"/>
+                <ns2:creationId id="{F363CDB4-E6DD-4E95-91B4-90BDE4A8D981}"/>
               </a:ext>
             </a:extLst>
           </p:cNvPr>
@@ -3875,7 +3875,7 @@
           <p:cNvPr id="11" name="Rounded Rectangle 10">
             <a:extLst>
               <a:ext uri="{FF2B5EF4-FFF2-40B4-BE49-F238E27FC236}">
-                <a16:creationId xmlns:a16="http://schemas.microsoft.com/office/drawing/2014/main" id="{9325C034-9199-4697-B618-6F70AB09830F}"/>
+                <ns2:creationId id="{9325C034-9199-4697-B618-6F70AB09830F}"/>
               </a:ext>
             </a:extLst>
           </p:cNvPr>
@@ -4102,7 +4102,7 @@
           <p:cNvPr id="12" name="Rounded Rectangle 11">
             <a:extLst>
               <a:ext uri="{FF2B5EF4-FFF2-40B4-BE49-F238E27FC236}">
-                <a16:creationId xmlns:a16="http://schemas.microsoft.com/office/drawing/2014/main" id="{50E7E727-B04E-4709-8FE5-CCB7471EF53A}"/>
+                <ns2:creationId id="{50E7E727-B04E-4709-8FE5-CCB7471EF53A}"/>
               </a:ext>
             </a:extLst>
           </p:cNvPr>
@@ -4179,7 +4179,7 @@
           <p:cNvPr id="13" name="Rounded Rectangle 12">
             <a:extLst>
               <a:ext uri="{FF2B5EF4-FFF2-40B4-BE49-F238E27FC236}">
-                <a16:creationId xmlns:a16="http://schemas.microsoft.com/office/drawing/2014/main" id="{6D35A37E-4535-47C6-A992-5CBD9D766AD9}"/>
+                <ns2:creationId id="{6D35A37E-4535-47C6-A992-5CBD9D766AD9}"/>
               </a:ext>
             </a:extLst>
           </p:cNvPr>
@@ -4256,7 +4256,7 @@
           <p:cNvPr id="14" name="Rounded Rectangle 13">
             <a:extLst>
               <a:ext uri="{FF2B5EF4-FFF2-40B4-BE49-F238E27FC236}">
-                <a16:creationId xmlns:a16="http://schemas.microsoft.com/office/drawing/2014/main" id="{A76EF416-4D56-4DEB-9130-4A1093C46786}"/>
+                <ns2:creationId id="{A76EF416-4D56-4DEB-9130-4A1093C46786}"/>
               </a:ext>
             </a:extLst>
           </p:cNvPr>
@@ -4333,7 +4333,7 @@
           <p:cNvPr id="15" name="Rounded Rectangle 14">
             <a:extLst>
               <a:ext uri="{FF2B5EF4-FFF2-40B4-BE49-F238E27FC236}">
-                <a16:creationId xmlns:a16="http://schemas.microsoft.com/office/drawing/2014/main" id="{241100B2-9425-49B3-BD3D-600C0EA2BA3B}"/>
+                <ns2:creationId id="{241100B2-9425-49B3-BD3D-600C0EA2BA3B}"/>
               </a:ext>
             </a:extLst>
           </p:cNvPr>
@@ -4410,7 +4410,7 @@
           <p:cNvPr id="16" name="Rounded Rectangle 15">
             <a:extLst>
               <a:ext uri="{FF2B5EF4-FFF2-40B4-BE49-F238E27FC236}">
-                <a16:creationId xmlns:a16="http://schemas.microsoft.com/office/drawing/2014/main" id="{3422EC93-3AE6-4FD1-86B9-CCE2E747E97C}"/>
+                <ns2:creationId id="{3422EC93-3AE6-4FD1-86B9-CCE2E747E97C}"/>
               </a:ext>
             </a:extLst>
           </p:cNvPr>
@@ -4496,7 +4496,7 @@
           <p:cNvPr id="17" name="Rounded Rectangle 16">
             <a:extLst>
               <a:ext uri="{FF2B5EF4-FFF2-40B4-BE49-F238E27FC236}">
-                <a16:creationId xmlns:a16="http://schemas.microsoft.com/office/drawing/2014/main" id="{637A9447-D148-4D93-B3FE-E7FEED877BA2}"/>
+                <ns2:creationId id="{637A9447-D148-4D93-B3FE-E7FEED877BA2}"/>
               </a:ext>
             </a:extLst>
           </p:cNvPr>
@@ -4582,7 +4582,7 @@
           <p:cNvPr id="18" name="TextBox 17">
             <a:extLst>
               <a:ext uri="{FF2B5EF4-FFF2-40B4-BE49-F238E27FC236}">
-                <a16:creationId xmlns:a16="http://schemas.microsoft.com/office/drawing/2014/main" id="{987B6C11-8EFC-4DFB-BFCB-B47005E29170}"/>
+                <ns2:creationId id="{987B6C11-8EFC-4DFB-BFCB-B47005E29170}"/>
               </a:ext>
             </a:extLst>
           </p:cNvPr>
@@ -4634,7 +4634,7 @@
           <p:cNvPr id="19" name="Rectangle 18">
             <a:extLst>
               <a:ext uri="{FF2B5EF4-FFF2-40B4-BE49-F238E27FC236}">
-                <a16:creationId xmlns:a16="http://schemas.microsoft.com/office/drawing/2014/main" id="{34888F7C-54D4-4508-B8D9-5E1B4555FCB9}"/>
+                <ns2:creationId id="{34888F7C-54D4-4508-B8D9-5E1B4555FCB9}"/>
               </a:ext>
             </a:extLst>
           </p:cNvPr>
@@ -4688,7 +4688,7 @@
           <p:cNvPr id="20" name="Rectangle 19">
             <a:extLst>
               <a:ext uri="{FF2B5EF4-FFF2-40B4-BE49-F238E27FC236}">
-                <a16:creationId xmlns:a16="http://schemas.microsoft.com/office/drawing/2014/main" id="{EF29820C-29E3-4D47-9261-6B47058FE73E}"/>
+                <ns2:creationId id="{EF29820C-29E3-4D47-9261-6B47058FE73E}"/>
               </a:ext>
             </a:extLst>
           </p:cNvPr>
@@ -4742,7 +4742,7 @@
           <p:cNvPr id="21" name="TextBox 20">
             <a:extLst>
               <a:ext uri="{FF2B5EF4-FFF2-40B4-BE49-F238E27FC236}">
-                <a16:creationId xmlns:a16="http://schemas.microsoft.com/office/drawing/2014/main" id="{E4E35181-C658-4DD7-BBA1-2169C2577EC9}"/>
+                <ns2:creationId id="{E4E35181-C658-4DD7-BBA1-2169C2577EC9}"/>
               </a:ext>
             </a:extLst>
           </p:cNvPr>
@@ -4789,7 +4789,7 @@
           <p:cNvPr id="22" name="TextBox 21">
             <a:extLst>
               <a:ext uri="{FF2B5EF4-FFF2-40B4-BE49-F238E27FC236}">
-                <a16:creationId xmlns:a16="http://schemas.microsoft.com/office/drawing/2014/main" id="{EF2E0CB2-56C2-4DB6-9C55-07C703BA1861}"/>
+                <ns2:creationId id="{EF2E0CB2-56C2-4DB6-9C55-07C703BA1861}"/>
               </a:ext>
             </a:extLst>
           </p:cNvPr>
@@ -4834,7 +4834,7 @@
     </p:spTree>
     <p:extLst>
       <p:ext uri="{BB962C8B-B14F-4D97-AF65-F5344CB8AC3E}">
-        <p14:creationId xmlns:p14="http://schemas.microsoft.com/office/powerpoint/2010/main" val="1483828426"/>
+        <ns4:creationId val="1483828426"/>
       </p:ext>
     </p:extLst>
   </p:cSld>

</xml_diff>